<commit_message>
feat: Enhance Streamlit Studio Pro frontend and add document management endpoints
- Upgraded frontend to modern cyber-glassmorphism dark UI with Plus Jakarta Sans & JetBrains Mono
- Added real-time token streaming animation and interactive citation cards with confidence meters
- Added categorized prompt suggestions library and 1-click sample dataset loader
- Added optimization presets, dynamic model detection, and session latency tracking charts
- Added multi-format chat export (Markdown and JSON) with user feedback options
- Implemented document management API routes, unit tests, and updated presentation deck
</commit_message>
<xml_diff>
--- a/RAG_Document_Assistant_Presentation.pptx
+++ b/RAG_Document_Assistant_Presentation.pptx
@@ -4656,7 +4656,7 @@
                         </a:defRPr>
                       </a:pPr>
                       <a:r>
-                        <a:t>Streamlit, Glassmorphism CSS</a:t>
+                        <a:t>Streamlit Studio Pro, Glassmorphism CSS</a:t>
                       </a:r>
                     </a:p>
                   </a:txBody>
@@ -4679,7 +4679,7 @@
                         </a:defRPr>
                       </a:pPr>
                       <a:r>
-                        <a:t>Diagnostic sidebar, chat history, collapsible source citation accordion</a:t>
+                        <a:t>Token streaming, citation cards with confidence meters, prompt library, presets, latency charts</a:t>
                       </a:r>
                     </a:p>
                   </a:txBody>
@@ -6257,7 +6257,7 @@
               </a:defRPr>
             </a:pPr>
             <a:r>
-              <a:t>🔒 100% Local &amp; Private</a:t>
+              <a:t>📁 Dynamic Multi-Format Ingestion</a:t>
             </a:r>
           </a:p>
           <a:p>
@@ -6272,7 +6272,7 @@
               </a:defRPr>
             </a:pPr>
             <a:r>
-              <a:t>Zero cloud API dependencies. Embedding generation and LLM execution run completely offline locally.</a:t>
+              <a:t>On-the-fly parsing &amp; embedding of PDF, TXT, and Markdown files with zero server restart required.</a:t>
             </a:r>
           </a:p>
         </p:txBody>
@@ -6326,7 +6326,7 @@
               </a:defRPr>
             </a:pPr>
             <a:r>
-              <a:t>🎯 Grounded &amp; Verifiable</a:t>
+              <a:t>🎯 Grounded &amp; Verifiable Citations</a:t>
             </a:r>
           </a:p>
           <a:p>
@@ -6341,7 +6341,7 @@
               </a:defRPr>
             </a:pPr>
             <a:r>
-              <a:t>Page-level source citations allow users to verify every sentence against original source PDFs.</a:t>
+              <a:t>Page-level source citations and confidence meters allow users to audit and verify every response.</a:t>
             </a:r>
           </a:p>
         </p:txBody>
@@ -6395,7 +6395,7 @@
               </a:defRPr>
             </a:pPr>
             <a:r>
-              <a:t>🛡️ Robust Guardrails</a:t>
+              <a:t>🛡️ Dual-Engine Offline Fallback</a:t>
             </a:r>
           </a:p>
           <a:p>
@@ -6410,7 +6410,7 @@
               </a:defRPr>
             </a:pPr>
             <a:r>
-              <a:t>Dual-layer fallback protection prevents hallucinations on ungrounded or off-topic queries.</a:t>
+              <a:t>High-fidelity Ollama LLM execution paired with an intelligent extractive fallback if offline.</a:t>
             </a:r>
           </a:p>
         </p:txBody>
@@ -6464,7 +6464,7 @@
               </a:defRPr>
             </a:pPr>
             <a:r>
-              <a:t>⚡ High Performance</a:t>
+              <a:t>⚡ 4-Tab Glassmorphism Studio Pro</a:t>
             </a:r>
           </a:p>
           <a:p>
@@ -6479,7 +6479,7 @@
               </a:defRPr>
             </a:pPr>
             <a:r>
-              <a:t>FastAPI lifespan caching loads vector models into memory ONCE for instant query processing.</a:t>
+              <a:t>Full workspace with real-time token streaming, prompt library, demo loader, presets, and latency analytics.</a:t>
             </a:r>
           </a:p>
         </p:txBody>

</xml_diff>

<commit_message>
feat(frontend): migrate from Streamlit to React 19 + Vite Pro Studio
</commit_message>
<xml_diff>
--- a/RAG_Document_Assistant_Presentation.pptx
+++ b/RAG_Document_Assistant_Presentation.pptx
@@ -3254,7 +3254,7 @@
               </a:defRPr>
             </a:pPr>
             <a:r>
-              <a:t>Technologies: FastAPI • ChromaDB • SentenceTransformers • Ollama (llama3:8b) • Streamlit</a:t>
+              <a:t>Technologies: FastAPI • ChromaDB • SentenceTransformers • Ollama (llama3:8b) • React + Vite</a:t>
             </a:r>
           </a:p>
         </p:txBody>
@@ -4101,7 +4101,7 @@
               </a:defRPr>
             </a:pPr>
             <a:r>
-              <a:t>👤 User submits query via Streamlit UI</a:t>
+              <a:t>👤 User submits query via React + Vite UI</a:t>
             </a:r>
           </a:p>
           <a:p>
@@ -4656,7 +4656,7 @@
                         </a:defRPr>
                       </a:pPr>
                       <a:r>
-                        <a:t>Streamlit Studio Pro, Glassmorphism CSS</a:t>
+                        <a:t>React 19, Vite, Glassmorphism CSS</a:t>
                       </a:r>
                     </a:p>
                   </a:txBody>
@@ -4679,7 +4679,7 @@
                         </a:defRPr>
                       </a:pPr>
                       <a:r>
-                        <a:t>Token streaming, citation cards with confidence meters, prompt library, presets, latency charts</a:t>
+                        <a:t>Real-time chat, citation cards with confidence meters, prompt library, visual PDF viewer, comparison matrix</a:t>
                       </a:r>
                     </a:p>
                   </a:txBody>
@@ -6724,7 +6724,7 @@
               </a:defRPr>
             </a:pPr>
             <a:r>
-              <a:t>✅ Modern Glassmorphism Streamlit UI</a:t>
+              <a:t>✅ Modern Glassmorphism React + Vite UI</a:t>
             </a:r>
           </a:p>
           <a:p>

</xml_diff>